<commit_message>
docs(pm): B090/B091 dispatched (พี่เปา issue2/3); B090→SongSheet dev, B091→editor dev; kanban→กำลังทำ
</commit_message>
<xml_diff>
--- a/docs/design/aim-whiteboard.pptx
+++ b/docs/design/aim-whiteboard.pptx
@@ -7,7 +7,6 @@
   <p:sldIdLst>
     <p:sldId id="256" r:id="rId2"/>
     <p:sldId id="257" r:id="rId3"/>
-    <p:sldId id="258" r:id="rId4"/>
   </p:sldIdLst>
   <p:sldSz cx="12192000" cy="6858000"/>
   <p:notesSz cx="6858000" cy="9144000"/>
@@ -261,7 +260,7 @@
           <a:p>
             <a:fld id="{54D898D7-6801-4465-8A62-D876BB2BDC27}" type="datetimeFigureOut">
               <a:rPr lang="en-US" smtClean="0"/>
-              <a:t>7/9/2026</a:t>
+              <a:t>7/10/2026</a:t>
             </a:fld>
             <a:endParaRPr lang="en-US"/>
           </a:p>
@@ -459,7 +458,7 @@
           <a:p>
             <a:fld id="{54D898D7-6801-4465-8A62-D876BB2BDC27}" type="datetimeFigureOut">
               <a:rPr lang="en-US" smtClean="0"/>
-              <a:t>7/9/2026</a:t>
+              <a:t>7/10/2026</a:t>
             </a:fld>
             <a:endParaRPr lang="en-US"/>
           </a:p>
@@ -667,7 +666,7 @@
           <a:p>
             <a:fld id="{54D898D7-6801-4465-8A62-D876BB2BDC27}" type="datetimeFigureOut">
               <a:rPr lang="en-US" smtClean="0"/>
-              <a:t>7/9/2026</a:t>
+              <a:t>7/10/2026</a:t>
             </a:fld>
             <a:endParaRPr lang="en-US"/>
           </a:p>
@@ -865,7 +864,7 @@
           <a:p>
             <a:fld id="{54D898D7-6801-4465-8A62-D876BB2BDC27}" type="datetimeFigureOut">
               <a:rPr lang="en-US" smtClean="0"/>
-              <a:t>7/9/2026</a:t>
+              <a:t>7/10/2026</a:t>
             </a:fld>
             <a:endParaRPr lang="en-US"/>
           </a:p>
@@ -1140,7 +1139,7 @@
           <a:p>
             <a:fld id="{54D898D7-6801-4465-8A62-D876BB2BDC27}" type="datetimeFigureOut">
               <a:rPr lang="en-US" smtClean="0"/>
-              <a:t>7/9/2026</a:t>
+              <a:t>7/10/2026</a:t>
             </a:fld>
             <a:endParaRPr lang="en-US"/>
           </a:p>
@@ -1405,7 +1404,7 @@
           <a:p>
             <a:fld id="{54D898D7-6801-4465-8A62-D876BB2BDC27}" type="datetimeFigureOut">
               <a:rPr lang="en-US" smtClean="0"/>
-              <a:t>7/9/2026</a:t>
+              <a:t>7/10/2026</a:t>
             </a:fld>
             <a:endParaRPr lang="en-US"/>
           </a:p>
@@ -1817,7 +1816,7 @@
           <a:p>
             <a:fld id="{54D898D7-6801-4465-8A62-D876BB2BDC27}" type="datetimeFigureOut">
               <a:rPr lang="en-US" smtClean="0"/>
-              <a:t>7/9/2026</a:t>
+              <a:t>7/10/2026</a:t>
             </a:fld>
             <a:endParaRPr lang="en-US"/>
           </a:p>
@@ -1958,7 +1957,7 @@
           <a:p>
             <a:fld id="{54D898D7-6801-4465-8A62-D876BB2BDC27}" type="datetimeFigureOut">
               <a:rPr lang="en-US" smtClean="0"/>
-              <a:t>7/9/2026</a:t>
+              <a:t>7/10/2026</a:t>
             </a:fld>
             <a:endParaRPr lang="en-US"/>
           </a:p>
@@ -2071,7 +2070,7 @@
           <a:p>
             <a:fld id="{54D898D7-6801-4465-8A62-D876BB2BDC27}" type="datetimeFigureOut">
               <a:rPr lang="en-US" smtClean="0"/>
-              <a:t>7/9/2026</a:t>
+              <a:t>7/10/2026</a:t>
             </a:fld>
             <a:endParaRPr lang="en-US"/>
           </a:p>
@@ -2382,7 +2381,7 @@
           <a:p>
             <a:fld id="{54D898D7-6801-4465-8A62-D876BB2BDC27}" type="datetimeFigureOut">
               <a:rPr lang="en-US" smtClean="0"/>
-              <a:t>7/9/2026</a:t>
+              <a:t>7/10/2026</a:t>
             </a:fld>
             <a:endParaRPr lang="en-US"/>
           </a:p>
@@ -2670,7 +2669,7 @@
           <a:p>
             <a:fld id="{54D898D7-6801-4465-8A62-D876BB2BDC27}" type="datetimeFigureOut">
               <a:rPr lang="en-US" smtClean="0"/>
-              <a:t>7/9/2026</a:t>
+              <a:t>7/10/2026</a:t>
             </a:fld>
             <a:endParaRPr lang="en-US"/>
           </a:p>
@@ -2911,7 +2910,7 @@
           <a:p>
             <a:fld id="{54D898D7-6801-4465-8A62-D876BB2BDC27}" type="datetimeFigureOut">
               <a:rPr lang="en-US" smtClean="0"/>
-              <a:t>7/9/2026</a:t>
+              <a:t>7/10/2026</a:t>
             </a:fld>
             <a:endParaRPr lang="en-US"/>
           </a:p>
@@ -4612,239 +4611,6 @@
 </p:sld>
 </file>
 
-<file path=ppt/slides/slide3.xml><?xml version="1.0" encoding="utf-8"?>
-<p:sld xmlns:a="http://schemas.openxmlformats.org/drawingml/2006/main" xmlns:r="http://schemas.openxmlformats.org/officeDocument/2006/relationships" xmlns:p="http://schemas.openxmlformats.org/presentationml/2006/main">
-  <p:cSld>
-    <p:spTree>
-      <p:nvGrpSpPr>
-        <p:cNvPr id="1" name=""/>
-        <p:cNvGrpSpPr/>
-        <p:nvPr/>
-      </p:nvGrpSpPr>
-      <p:grpSpPr>
-        <a:xfrm>
-          <a:off x="0" y="0"/>
-          <a:ext cx="0" cy="0"/>
-          <a:chOff x="0" y="0"/>
-          <a:chExt cx="0" cy="0"/>
-        </a:xfrm>
-      </p:grpSpPr>
-      <p:sp>
-        <p:nvSpPr>
-          <p:cNvPr id="18" name="Rectangle 17">
-            <a:extLst>
-              <a:ext uri="{FF2B5EF4-FFF2-40B4-BE49-F238E27FC236}">
-                <a16:creationId xmlns:a16="http://schemas.microsoft.com/office/drawing/2014/main" id="{B55E0ABF-0DE5-FBE0-101D-43CF8905C870}"/>
-              </a:ext>
-            </a:extLst>
-          </p:cNvPr>
-          <p:cNvSpPr/>
-          <p:nvPr/>
-        </p:nvSpPr>
-        <p:spPr>
-          <a:xfrm>
-            <a:off x="1751978" y="839972"/>
-            <a:ext cx="8545655" cy="2068033"/>
-          </a:xfrm>
-          <a:prstGeom prst="rect">
-            <a:avLst/>
-          </a:prstGeom>
-          <a:noFill/>
-        </p:spPr>
-        <p:style>
-          <a:lnRef idx="2">
-            <a:schemeClr val="accent1">
-              <a:shade val="15000"/>
-            </a:schemeClr>
-          </a:lnRef>
-          <a:fillRef idx="1">
-            <a:schemeClr val="accent1"/>
-          </a:fillRef>
-          <a:effectRef idx="0">
-            <a:schemeClr val="accent1"/>
-          </a:effectRef>
-          <a:fontRef idx="minor">
-            <a:schemeClr val="lt1"/>
-          </a:fontRef>
-        </p:style>
-        <p:txBody>
-          <a:bodyPr rtlCol="0" anchor="ctr"/>
-          <a:lstStyle/>
-          <a:p>
-            <a:pPr algn="ctr"/>
-            <a:endParaRPr lang="en-US"/>
-          </a:p>
-        </p:txBody>
-      </p:sp>
-      <p:pic>
-        <p:nvPicPr>
-          <p:cNvPr id="7" name="Picture 6">
-            <a:extLst>
-              <a:ext uri="{FF2B5EF4-FFF2-40B4-BE49-F238E27FC236}">
-                <a16:creationId xmlns:a16="http://schemas.microsoft.com/office/drawing/2014/main" id="{A5F16F71-2DE3-BDD9-62FD-B7A69274E011}"/>
-              </a:ext>
-            </a:extLst>
-          </p:cNvPr>
-          <p:cNvPicPr>
-            <a:picLocks noChangeAspect="1"/>
-          </p:cNvPicPr>
-          <p:nvPr/>
-        </p:nvPicPr>
-        <p:blipFill>
-          <a:blip r:embed="rId2"/>
-          <a:stretch>
-            <a:fillRect/>
-          </a:stretch>
-        </p:blipFill>
-        <p:spPr>
-          <a:xfrm>
-            <a:off x="1985894" y="946742"/>
-            <a:ext cx="733425" cy="771525"/>
-          </a:xfrm>
-          <a:prstGeom prst="rect">
-            <a:avLst/>
-          </a:prstGeom>
-        </p:spPr>
-      </p:pic>
-      <p:pic>
-        <p:nvPicPr>
-          <p:cNvPr id="11" name="Picture 10" descr="The image displays a digital interface with a play button, a drag and drop feature, and a tube icon, along with a time stamp of 0:07 followed by an 'O' and a time stamp of 1:37.&#10;&#10;AI-generated content may be incorrect.">
-            <a:extLst>
-              <a:ext uri="{FF2B5EF4-FFF2-40B4-BE49-F238E27FC236}">
-                <a16:creationId xmlns:a16="http://schemas.microsoft.com/office/drawing/2014/main" id="{C33F0EBF-F98D-2C2E-1787-D223FC139950}"/>
-              </a:ext>
-            </a:extLst>
-          </p:cNvPr>
-          <p:cNvPicPr>
-            <a:picLocks noChangeAspect="1"/>
-          </p:cNvPicPr>
-          <p:nvPr/>
-        </p:nvPicPr>
-        <p:blipFill>
-          <a:blip r:embed="rId3"/>
-          <a:stretch>
-            <a:fillRect/>
-          </a:stretch>
-        </p:blipFill>
-        <p:spPr>
-          <a:xfrm>
-            <a:off x="2822944" y="987113"/>
-            <a:ext cx="7285074" cy="690784"/>
-          </a:xfrm>
-          <a:prstGeom prst="rect">
-            <a:avLst/>
-          </a:prstGeom>
-        </p:spPr>
-      </p:pic>
-      <p:pic>
-        <p:nvPicPr>
-          <p:cNvPr id="13" name="Picture 12" descr="The image shows a white arrow pointing to the right and a white arrow pointing to the left.&#10;&#10;AI-generated content may be incorrect.">
-            <a:extLst>
-              <a:ext uri="{FF2B5EF4-FFF2-40B4-BE49-F238E27FC236}">
-                <a16:creationId xmlns:a16="http://schemas.microsoft.com/office/drawing/2014/main" id="{D35FCF75-BCB0-D079-7B6D-404C6EED7BC9}"/>
-              </a:ext>
-            </a:extLst>
-          </p:cNvPr>
-          <p:cNvPicPr>
-            <a:picLocks noChangeAspect="1"/>
-          </p:cNvPicPr>
-          <p:nvPr/>
-        </p:nvPicPr>
-        <p:blipFill>
-          <a:blip r:embed="rId4"/>
-          <a:stretch>
-            <a:fillRect/>
-          </a:stretch>
-        </p:blipFill>
-        <p:spPr>
-          <a:xfrm>
-            <a:off x="2870790" y="1890520"/>
-            <a:ext cx="1310192" cy="601296"/>
-          </a:xfrm>
-          <a:prstGeom prst="rect">
-            <a:avLst/>
-          </a:prstGeom>
-        </p:spPr>
-      </p:pic>
-      <p:pic>
-        <p:nvPicPr>
-          <p:cNvPr id="17" name="Picture 16" descr="A simple, white, circular icon with a central gear pattern.&#10;&#10;AI-generated content may be incorrect.">
-            <a:extLst>
-              <a:ext uri="{FF2B5EF4-FFF2-40B4-BE49-F238E27FC236}">
-                <a16:creationId xmlns:a16="http://schemas.microsoft.com/office/drawing/2014/main" id="{8051CB24-4A9D-52BD-4356-9ED269C5A6FD}"/>
-              </a:ext>
-            </a:extLst>
-          </p:cNvPr>
-          <p:cNvPicPr>
-            <a:picLocks noChangeAspect="1"/>
-          </p:cNvPicPr>
-          <p:nvPr/>
-        </p:nvPicPr>
-        <p:blipFill>
-          <a:blip r:embed="rId5"/>
-          <a:stretch>
-            <a:fillRect/>
-          </a:stretch>
-        </p:blipFill>
-        <p:spPr>
-          <a:xfrm>
-            <a:off x="1985894" y="1938365"/>
-            <a:ext cx="763138" cy="771525"/>
-          </a:xfrm>
-          <a:prstGeom prst="rect">
-            <a:avLst/>
-          </a:prstGeom>
-        </p:spPr>
-      </p:pic>
-      <p:sp>
-        <p:nvSpPr>
-          <p:cNvPr id="19" name="TextBox 18">
-            <a:extLst>
-              <a:ext uri="{FF2B5EF4-FFF2-40B4-BE49-F238E27FC236}">
-                <a16:creationId xmlns:a16="http://schemas.microsoft.com/office/drawing/2014/main" id="{2E25D5E1-95D2-D8FB-FE83-C65C549315C9}"/>
-              </a:ext>
-            </a:extLst>
-          </p:cNvPr>
-          <p:cNvSpPr txBox="1"/>
-          <p:nvPr/>
-        </p:nvSpPr>
-        <p:spPr>
-          <a:xfrm>
-            <a:off x="5548424" y="1968596"/>
-            <a:ext cx="1527982" cy="523220"/>
-          </a:xfrm>
-          <a:prstGeom prst="rect">
-            <a:avLst/>
-          </a:prstGeom>
-          <a:noFill/>
-        </p:spPr>
-        <p:txBody>
-          <a:bodyPr wrap="none" rtlCol="0">
-            <a:spAutoFit/>
-          </a:bodyPr>
-          <a:lstStyle/>
-          <a:p>
-            <a:r>
-              <a:rPr lang="th-TH" sz="2800" b="1" dirty="0"/>
-              <a:t>...ปุ่มอื่น ๆ...</a:t>
-            </a:r>
-            <a:endParaRPr lang="en-US" sz="2800" b="1" dirty="0"/>
-          </a:p>
-        </p:txBody>
-      </p:sp>
-    </p:spTree>
-    <p:extLst>
-      <p:ext uri="{BB962C8B-B14F-4D97-AF65-F5344CB8AC3E}">
-        <p14:creationId xmlns:p14="http://schemas.microsoft.com/office/powerpoint/2010/main" val="3434095319"/>
-      </p:ext>
-    </p:extLst>
-  </p:cSld>
-  <p:clrMapOvr>
-    <a:masterClrMapping/>
-  </p:clrMapOvr>
-</p:sld>
-</file>
-
 <file path=ppt/theme/theme1.xml><?xml version="1.0" encoding="utf-8"?>
 <a:theme xmlns:a="http://schemas.openxmlformats.org/drawingml/2006/main" name="Office Theme">
   <a:themeElements>

</xml_diff>